<commit_message>
feat(site): improve logo visibility in nav and add hero branding
Nav: increase logo from 28px to 38px, add dark pill backdrop for
contrast in both themes, remove circular crop that cut spiral arcs.

Hero: add 140px spiral mark left of title text in flex layout with
subtle blue glow. Stacks vertically on mobile (100px).

Also updates LinkedIn carousel with spiral branding.

Co-Authored-By: Claude Opus 4.6 (1M context) <noreply@anthropic.com>
</commit_message>
<xml_diff>
--- a/dissemination/assets/linkedin-carousel.pptx
+++ b/dissemination/assets/linkedin-carousel.pptx
@@ -3182,16 +3182,40 @@
           </a:p>
         </p:txBody>
       </p:sp>
-      <p:sp>
-        <p:nvSpPr>
-          <p:cNvPr id="4" name="TextBox 3"/>
+      <p:pic>
+        <p:nvPicPr>
+          <p:cNvPr id="4" name="Picture 3" descr="image.png"/>
+          <p:cNvPicPr>
+            <a:picLocks noChangeAspect="1"/>
+          </p:cNvPicPr>
+          <p:nvPr/>
+        </p:nvPicPr>
+        <p:blipFill>
+          <a:blip r:embed="rId2"/>
+          <a:stretch>
+            <a:fillRect/>
+          </a:stretch>
+        </p:blipFill>
+        <p:spPr>
+          <a:xfrm>
+            <a:off x="3291840" y="502920"/>
+            <a:ext cx="2560320" cy="2560320"/>
+          </a:xfrm>
+          <a:prstGeom prst="rect">
+            <a:avLst/>
+          </a:prstGeom>
+        </p:spPr>
+      </p:pic>
+      <p:sp>
+        <p:nvSpPr>
+          <p:cNvPr id="5" name="TextBox 4"/>
           <p:cNvSpPr txBox="1"/>
           <p:nvPr/>
         </p:nvSpPr>
         <p:spPr>
           <a:xfrm>
-            <a:off x="640080" y="2560320"/>
-            <a:ext cx="7863840" cy="1645920"/>
+            <a:off x="640080" y="3246120"/>
+            <a:ext cx="7863840" cy="1280160"/>
           </a:xfrm>
           <a:prstGeom prst="rect">
             <a:avLst/>
@@ -3219,13 +3243,13 @@
       </p:sp>
       <p:sp>
         <p:nvSpPr>
-          <p:cNvPr id="5" name="Rectangle 4"/>
+          <p:cNvPr id="6" name="Rectangle 5"/>
           <p:cNvSpPr/>
           <p:nvPr/>
         </p:nvSpPr>
         <p:spPr>
           <a:xfrm>
-            <a:off x="3200400" y="4434840"/>
+            <a:off x="3200400" y="4663440"/>
             <a:ext cx="2743200" cy="50800"/>
           </a:xfrm>
           <a:prstGeom prst="rect">
@@ -3262,13 +3286,13 @@
       </p:sp>
       <p:sp>
         <p:nvSpPr>
-          <p:cNvPr id="6" name="TextBox 5"/>
+          <p:cNvPr id="7" name="TextBox 6"/>
           <p:cNvSpPr txBox="1"/>
           <p:nvPr/>
         </p:nvSpPr>
         <p:spPr>
           <a:xfrm>
-            <a:off x="640080" y="4663440"/>
+            <a:off x="640080" y="4892040"/>
             <a:ext cx="7863840" cy="822960"/>
           </a:xfrm>
           <a:prstGeom prst="rect">
@@ -3297,13 +3321,13 @@
       </p:sp>
       <p:sp>
         <p:nvSpPr>
-          <p:cNvPr id="7" name="TextBox 6"/>
+          <p:cNvPr id="8" name="TextBox 7"/>
           <p:cNvSpPr txBox="1"/>
           <p:nvPr/>
         </p:nvSpPr>
         <p:spPr>
           <a:xfrm>
-            <a:off x="640080" y="5669280"/>
+            <a:off x="640080" y="5897880"/>
             <a:ext cx="7863840" cy="640080"/>
           </a:xfrm>
           <a:prstGeom prst="rect">
@@ -3332,7 +3356,7 @@
       </p:sp>
       <p:sp>
         <p:nvSpPr>
-          <p:cNvPr id="8" name="Rectangle 7"/>
+          <p:cNvPr id="9" name="Rectangle 8"/>
           <p:cNvSpPr/>
           <p:nvPr/>
         </p:nvSpPr>
@@ -3375,7 +3399,7 @@
       </p:sp>
       <p:sp>
         <p:nvSpPr>
-          <p:cNvPr id="9" name="TextBox 8"/>
+          <p:cNvPr id="10" name="TextBox 9"/>
           <p:cNvSpPr txBox="1"/>
           <p:nvPr/>
         </p:nvSpPr>

</xml_diff>